<commit_message>
feat(ppt): embed real system screenshots into defense slides
- Capture 8 screenshots via Playwright: login, dashboard, resources, qa,
  statistics, recommendations, plan, profile
- Embed screenshots into slides 3, 6, 8-11, 14, 17 of the defense PPT
- Update docs/PPT_CHECKLIST.md and docs/PPT_PRODUCTION_PLAN.md status
- Note PDF export remains manual due to missing LibreOffice/PowerPoint COM

Co-Authored-By: Claude Fable 5 <noreply@anthropic.com>
</commit_message>
<xml_diff>
--- a/assets/ppt/公务员考试学习跟踪系统答辩.pptx
+++ b/assets/ppt/公务员考试学习跟踪系统答辩.pptx
@@ -5213,6 +5213,30 @@
           </a:p>
         </p:txBody>
       </p:sp>
+      <p:pic>
+        <p:nvPicPr>
+          <p:cNvPr id="19" name="Picture 18" descr="statistics.png"/>
+          <p:cNvPicPr>
+            <a:picLocks noChangeAspect="1"/>
+          </p:cNvPicPr>
+          <p:nvPr/>
+        </p:nvPicPr>
+        <p:blipFill>
+          <a:blip r:embed="rId3"/>
+          <a:stretch>
+            <a:fillRect/>
+          </a:stretch>
+        </p:blipFill>
+        <p:spPr>
+          <a:xfrm>
+            <a:off x="608990" y="1714500"/>
+            <a:ext cx="10972800" cy="5515467"/>
+          </a:xfrm>
+          <a:prstGeom prst="rect">
+            <a:avLst/>
+          </a:prstGeom>
+        </p:spPr>
+      </p:pic>
     </p:spTree>
   </p:cSld>
   <p:clrMapOvr>
@@ -6042,6 +6066,30 @@
           </a:p>
         </p:txBody>
       </p:sp>
+      <p:pic>
+        <p:nvPicPr>
+          <p:cNvPr id="25" name="Picture 24" descr="recommendations.png"/>
+          <p:cNvPicPr>
+            <a:picLocks noChangeAspect="1"/>
+          </p:cNvPicPr>
+          <p:nvPr/>
+        </p:nvPicPr>
+        <p:blipFill>
+          <a:blip r:embed="rId3"/>
+          <a:stretch>
+            <a:fillRect/>
+          </a:stretch>
+        </p:blipFill>
+        <p:spPr>
+          <a:xfrm>
+            <a:off x="608990" y="1714500"/>
+            <a:ext cx="10972800" cy="5515467"/>
+          </a:xfrm>
+          <a:prstGeom prst="rect">
+            <a:avLst/>
+          </a:prstGeom>
+        </p:spPr>
+      </p:pic>
     </p:spTree>
   </p:cSld>
   <p:clrMapOvr>
@@ -8687,6 +8735,30 @@
           </a:p>
         </p:txBody>
       </p:sp>
+      <p:pic>
+        <p:nvPicPr>
+          <p:cNvPr id="34" name="Picture 33" descr="dashboard.png"/>
+          <p:cNvPicPr>
+            <a:picLocks noChangeAspect="1"/>
+          </p:cNvPicPr>
+          <p:nvPr/>
+        </p:nvPicPr>
+        <p:blipFill>
+          <a:blip r:embed="rId3"/>
+          <a:stretch>
+            <a:fillRect/>
+          </a:stretch>
+        </p:blipFill>
+        <p:spPr>
+          <a:xfrm>
+            <a:off x="608990" y="1714500"/>
+            <a:ext cx="10972800" cy="5515467"/>
+          </a:xfrm>
+          <a:prstGeom prst="rect">
+            <a:avLst/>
+          </a:prstGeom>
+        </p:spPr>
+      </p:pic>
     </p:spTree>
   </p:cSld>
   <p:clrMapOvr>
@@ -11544,6 +11616,30 @@
           </a:p>
         </p:txBody>
       </p:sp>
+      <p:pic>
+        <p:nvPicPr>
+          <p:cNvPr id="52" name="Picture 51" descr="profile.png"/>
+          <p:cNvPicPr>
+            <a:picLocks noChangeAspect="1"/>
+          </p:cNvPicPr>
+          <p:nvPr/>
+        </p:nvPicPr>
+        <p:blipFill>
+          <a:blip r:embed="rId3"/>
+          <a:stretch>
+            <a:fillRect/>
+          </a:stretch>
+        </p:blipFill>
+        <p:spPr>
+          <a:xfrm>
+            <a:off x="608990" y="1714500"/>
+            <a:ext cx="10972800" cy="5515467"/>
+          </a:xfrm>
+          <a:prstGeom prst="rect">
+            <a:avLst/>
+          </a:prstGeom>
+        </p:spPr>
+      </p:pic>
     </p:spTree>
   </p:cSld>
   <p:clrMapOvr>
@@ -13923,6 +14019,30 @@
           </a:p>
         </p:txBody>
       </p:sp>
+      <p:pic>
+        <p:nvPicPr>
+          <p:cNvPr id="20" name="Picture 19" descr="login.png"/>
+          <p:cNvPicPr>
+            <a:picLocks noChangeAspect="1"/>
+          </p:cNvPicPr>
+          <p:nvPr/>
+        </p:nvPicPr>
+        <p:blipFill>
+          <a:blip r:embed="rId3"/>
+          <a:stretch>
+            <a:fillRect/>
+          </a:stretch>
+        </p:blipFill>
+        <p:spPr>
+          <a:xfrm>
+            <a:off x="608990" y="1714500"/>
+            <a:ext cx="10972800" cy="5515467"/>
+          </a:xfrm>
+          <a:prstGeom prst="rect">
+            <a:avLst/>
+          </a:prstGeom>
+        </p:spPr>
+      </p:pic>
     </p:spTree>
   </p:cSld>
   <p:clrMapOvr>
@@ -16586,6 +16706,30 @@
           </a:p>
         </p:txBody>
       </p:sp>
+      <p:pic>
+        <p:nvPicPr>
+          <p:cNvPr id="25" name="Picture 24" descr="resources.png"/>
+          <p:cNvPicPr>
+            <a:picLocks noChangeAspect="1"/>
+          </p:cNvPicPr>
+          <p:nvPr/>
+        </p:nvPicPr>
+        <p:blipFill>
+          <a:blip r:embed="rId3"/>
+          <a:stretch>
+            <a:fillRect/>
+          </a:stretch>
+        </p:blipFill>
+        <p:spPr>
+          <a:xfrm>
+            <a:off x="608990" y="1714500"/>
+            <a:ext cx="10972800" cy="5515467"/>
+          </a:xfrm>
+          <a:prstGeom prst="rect">
+            <a:avLst/>
+          </a:prstGeom>
+        </p:spPr>
+      </p:pic>
     </p:spTree>
   </p:cSld>
   <p:clrMapOvr>
@@ -18465,6 +18609,30 @@
           </a:p>
         </p:txBody>
       </p:sp>
+      <p:pic>
+        <p:nvPicPr>
+          <p:cNvPr id="28" name="Picture 27" descr="qa.png"/>
+          <p:cNvPicPr>
+            <a:picLocks noChangeAspect="1"/>
+          </p:cNvPicPr>
+          <p:nvPr/>
+        </p:nvPicPr>
+        <p:blipFill>
+          <a:blip r:embed="rId3"/>
+          <a:stretch>
+            <a:fillRect/>
+          </a:stretch>
+        </p:blipFill>
+        <p:spPr>
+          <a:xfrm>
+            <a:off x="608990" y="1714500"/>
+            <a:ext cx="10972800" cy="5515467"/>
+          </a:xfrm>
+          <a:prstGeom prst="rect">
+            <a:avLst/>
+          </a:prstGeom>
+        </p:spPr>
+      </p:pic>
     </p:spTree>
   </p:cSld>
   <p:clrMapOvr>
@@ -19550,6 +19718,30 @@
           </a:p>
         </p:txBody>
       </p:sp>
+      <p:pic>
+        <p:nvPicPr>
+          <p:cNvPr id="33" name="Picture 32" descr="plan.png"/>
+          <p:cNvPicPr>
+            <a:picLocks noChangeAspect="1"/>
+          </p:cNvPicPr>
+          <p:nvPr/>
+        </p:nvPicPr>
+        <p:blipFill>
+          <a:blip r:embed="rId3"/>
+          <a:stretch>
+            <a:fillRect/>
+          </a:stretch>
+        </p:blipFill>
+        <p:spPr>
+          <a:xfrm>
+            <a:off x="608990" y="1714500"/>
+            <a:ext cx="10972800" cy="5515467"/>
+          </a:xfrm>
+          <a:prstGeom prst="rect">
+            <a:avLst/>
+          </a:prstGeom>
+        </p:spPr>
+      </p:pic>
     </p:spTree>
   </p:cSld>
   <p:clrMapOvr>

</xml_diff>